<commit_message>
KB deck baseline: v6 with Tyler's deletions
</commit_message>
<xml_diff>
--- a/docs/kb/decks/khonsu_story_2026-09-04.pptx
+++ b/docs/kb/decks/khonsu_story_2026-09-04.pptx
@@ -3193,7 +3193,7 @@
         <p:spPr>
           <a:xfrm>
             <a:off x="900000" y="4300000"/>
-            <a:ext cx="10392000" cy="700000"/>
+            <a:ext cx="10392000" cy="500000"/>
           </a:xfrm>
           <a:prstGeom prst="rect">
             <a:avLst/>
@@ -3205,21 +3205,6 @@
             <a:spAutoFit/>
           </a:bodyPr>
           <a:lstStyle/>
-          <a:p>
-            <a:pPr algn="ctr">
-              <a:spcAft>
-                <a:spcPts val="600"/>
-              </a:spcAft>
-            </a:pPr>
-            <a:r>
-              <a:rPr sz="1300" b="0">
-                <a:solidFill>
-                  <a:srgbClr val="B3A369"/>
-                </a:solidFill>
-              </a:rPr>
-              <a:t>Status labels on evidence slides  ·  Done  ·  Provisional  ·  Running  ·  Needed</a:t>
-            </a:r>
-          </a:p>
           <a:p>
             <a:pPr algn="ctr">
               <a:spcAft>
@@ -8386,44 +8371,6 @@
                 </a:solidFill>
               </a:rPr>
               <a:t>• We know how to operate one locale.</a:t>
-            </a:r>
-          </a:p>
-        </p:txBody>
-      </p:sp>
-      <p:sp>
-        <p:nvSpPr>
-          <p:cNvPr id="5" name="TextBox 4"/>
-          <p:cNvSpPr txBox="1"/>
-          <p:nvPr/>
-        </p:nvSpPr>
-        <p:spPr>
-          <a:xfrm>
-            <a:off x="640080" y="6263640"/>
-            <a:ext cx="10972800" cy="457200"/>
-          </a:xfrm>
-          <a:prstGeom prst="rect">
-            <a:avLst/>
-          </a:prstGeom>
-          <a:noFill/>
-        </p:spPr>
-        <p:txBody>
-          <a:bodyPr wrap="square">
-            <a:spAutoFit/>
-          </a:bodyPr>
-          <a:lstStyle/>
-          <a:p>
-            <a:pPr>
-              <a:spcAft>
-                <a:spcPts val="600"/>
-              </a:spcAft>
-            </a:pPr>
-            <a:r>
-              <a:rPr sz="1200" b="0">
-                <a:solidFill>
-                  <a:srgbClr val="B3A369"/>
-                </a:solidFill>
-              </a:rPr>
-              <a:t>Landle et al., Scalable Edge-assisted Fusion and Path Prediction for Connected Autonomous Vehicles, SEC 2026</a:t>
             </a:r>
           </a:p>
         </p:txBody>
@@ -10115,44 +10062,6 @@
           </a:prstGeom>
         </p:spPr>
       </p:pic>
-      <p:sp>
-        <p:nvSpPr>
-          <p:cNvPr id="8" name="TextBox 7"/>
-          <p:cNvSpPr txBox="1"/>
-          <p:nvPr/>
-        </p:nvSpPr>
-        <p:spPr>
-          <a:xfrm>
-            <a:off x="640080" y="6263640"/>
-            <a:ext cx="10972800" cy="457200"/>
-          </a:xfrm>
-          <a:prstGeom prst="rect">
-            <a:avLst/>
-          </a:prstGeom>
-          <a:noFill/>
-        </p:spPr>
-        <p:txBody>
-          <a:bodyPr wrap="square">
-            <a:spAutoFit/>
-          </a:bodyPr>
-          <a:lstStyle/>
-          <a:p>
-            <a:pPr>
-              <a:spcAft>
-                <a:spcPts val="600"/>
-              </a:spcAft>
-            </a:pPr>
-            <a:r>
-              <a:rPr sz="1200" b="0">
-                <a:solidFill>
-                  <a:srgbClr val="B3A369"/>
-                </a:solidFill>
-              </a:rPr>
-              <a:t>Evidence: partition of a CARLA town under the measured cap  ·  Missing: sizing study on measured density traces</a:t>
-            </a:r>
-          </a:p>
-        </p:txBody>
-      </p:sp>
     </p:spTree>
   </p:cSld>
   <p:clrMapOvr>

</xml_diff>

<commit_message>
KB deck baseline updated
</commit_message>
<xml_diff>
--- a/docs/kb/decks/khonsu_story_2026-09-04.pptx
+++ b/docs/kb/decks/khonsu_story_2026-09-04.pptx
@@ -3184,44 +3184,6 @@
           </a:p>
         </p:txBody>
       </p:sp>
-      <p:sp>
-        <p:nvSpPr>
-          <p:cNvPr id="4" name="TextBox 3"/>
-          <p:cNvSpPr txBox="1"/>
-          <p:nvPr/>
-        </p:nvSpPr>
-        <p:spPr>
-          <a:xfrm>
-            <a:off x="900000" y="4300000"/>
-            <a:ext cx="10392000" cy="500000"/>
-          </a:xfrm>
-          <a:prstGeom prst="rect">
-            <a:avLst/>
-          </a:prstGeom>
-          <a:noFill/>
-        </p:spPr>
-        <p:txBody>
-          <a:bodyPr wrap="square">
-            <a:spAutoFit/>
-          </a:bodyPr>
-          <a:lstStyle/>
-          <a:p>
-            <a:pPr algn="ctr">
-              <a:spcAft>
-                <a:spcPts val="600"/>
-              </a:spcAft>
-            </a:pPr>
-            <a:r>
-              <a:rPr sz="1300" b="0">
-                <a:solidFill>
-                  <a:srgbClr val="B3A369"/>
-                </a:solidFill>
-              </a:rPr>
-              <a:t>Dashed figures with the red banner are expected shapes, not measurements</a:t>
-            </a:r>
-          </a:p>
-        </p:txBody>
-      </p:sp>
     </p:spTree>
   </p:cSld>
   <p:clrMapOvr>
@@ -3872,7 +3834,7 @@
             <a:avLst/>
           </a:prstGeom>
           <a:solidFill>
-            <a:srgbClr val="D68C00"/>
+            <a:srgbClr val="2E7D32"/>
           </a:solidFill>
           <a:ln>
             <a:noFill/>
@@ -3903,7 +3865,7 @@
                   <a:srgbClr val="FFFFFF"/>
                 </a:solidFill>
               </a:rPr>
-              <a:t>Provisional</a:t>
+              <a:t>Done</a:t>
             </a:r>
           </a:p>
         </p:txBody>
@@ -3986,7 +3948,37 @@
                   <a:srgbClr val="212121"/>
                 </a:solidFill>
               </a:rPr>
-              <a:t>• Lead-time sweep (Provisional). Completion rises with lead up to 4 s, on an unvalidated geometry, v3 running.</a:t>
+              <a:t>• v3 re-baseline (Done). Corrected scenario, 10 runs per arm. History at crossing 9 of 10 clean, history 1 s ahead 7 of 10, Kalman 2 of 10, cold 2 of 10, EdgeWarp timing 0 of 10.</a:t>
+            </a:r>
+          </a:p>
+          <a:p>
+            <a:pPr>
+              <a:spcAft>
+                <a:spcPts val="800"/>
+              </a:spcAft>
+            </a:pPr>
+            <a:r>
+              <a:rPr sz="1600" b="0">
+                <a:solidFill>
+                  <a:srgbClr val="212121"/>
+                </a:solidFill>
+              </a:rPr>
+              <a:t>• Burst (Done). Five-vehicle platoon on one boundary. History ahead 5 of 5 clean, EdgeWarp timing 0 of 5, cold 0 of 5.</a:t>
+            </a:r>
+          </a:p>
+          <a:p>
+            <a:pPr>
+              <a:spcAft>
+                <a:spcPts val="800"/>
+              </a:spcAft>
+            </a:pPr>
+            <a:r>
+              <a:rPr sz="1600" b="0">
+                <a:solidFill>
+                  <a:srgbClr val="212121"/>
+                </a:solidFill>
+              </a:rPr>
+              <a:t>• Lead-time sweep (Provisional). The v1 curve was on an unvalidated geometry. On the corrected geometry the source sees the actor, so at-crossing transfer suffices. The trigger table decides timing.</a:t>
             </a:r>
           </a:p>
         </p:txBody>
@@ -4007,8 +3999,8 @@
         </p:blipFill>
         <p:spPr>
           <a:xfrm>
-            <a:off x="2600000" y="2900000"/>
-            <a:ext cx="6500000" cy="3250000"/>
+            <a:off x="2600000" y="3700000"/>
+            <a:ext cx="4900000" cy="2450000"/>
           </a:xfrm>
           <a:prstGeom prst="rect">
             <a:avLst/>
@@ -4048,7 +4040,7 @@
                   <a:srgbClr val="B3A369"/>
                 </a:solidFill>
               </a:rPr>
-              <a:t>Missing: computed trigger vs fixed leads on the corrected scenario, live fault arms with the epoch check on and off</a:t>
+              <a:t>Missing: predictor-mode trigger and lead sweep on the corrected scenario (T15), live fault arms with the epoch check on and off</a:t>
             </a:r>
           </a:p>
         </p:txBody>
@@ -8686,7 +8678,7 @@
                     <a:p>
                       <a:r>
                         <a:rPr sz="1200" b="0"/>
-                        <a:t>8-scenario ownership faults, age chain</a:t>
+                        <a:t>v3 flow table (history 9/10 and 7/10 vs 0 to 2/10), 8-scenario ownership faults, age chain</a:t>
                       </a:r>
                     </a:p>
                   </a:txBody>
@@ -8699,7 +8691,7 @@
                     <a:p>
                       <a:r>
                         <a:rPr sz="1200" b="0"/>
-                        <a:t>v3 re-baseline, computed vs fixed lead</a:t>
+                        <a:t>q5 crossing rate, lookahead redo, computed-lead fix</a:t>
                       </a:r>
                     </a:p>
                   </a:txBody>
@@ -8712,7 +8704,7 @@
                     <a:p>
                       <a:r>
                         <a:rPr sz="1200" b="0"/>
-                        <a:t>safe-age limits (T12), live fault arms (T7), real transport (T8), overlap sweep and dual authority (T14)</a:t>
+                        <a:t>safe-age limits (T12), predictor-mode trigger (T15), live fault arms (T7), real transport (T8), overlap sweep (T14)</a:t>
                       </a:r>
                     </a:p>
                   </a:txBody>
@@ -8757,7 +8749,7 @@
                     <a:p>
                       <a:r>
                         <a:rPr sz="1200" b="0"/>
-                        <a:t>harness, knobs, burst scenario</a:t>
+                        <a:t>burst: history ahead 5/5 vs EdgeWarp 0/5 vs cold 0/5</a:t>
                       </a:r>
                     </a:p>
                   </a:txBody>
@@ -8770,7 +8762,7 @@
                     <a:p>
                       <a:r>
                         <a:rPr sz="1200" b="0"/>
-                        <a:t>crossing-rate sweep (q5)</a:t>
+                        <a:t>crossing-rate sweep (q5), corridor build (T13)</a:t>
                       </a:r>
                     </a:p>
                   </a:txBody>
@@ -8783,7 +8775,7 @@
                     <a:p>
                       <a:r>
                         <a:rPr sz="1200" b="0"/>
-                        <a:t>corridor scenario and route-level metrics (T13), association for unconnected actors (T10)</a:t>
+                        <a:t>corridor route-level metrics (T13), association for unconnected actors (T10)</a:t>
                       </a:r>
                     </a:p>
                   </a:txBody>
@@ -8797,10 +8789,10 @@
                       <a:r>
                         <a:rPr sz="1200" b="1">
                           <a:solidFill>
-                            <a:srgbClr val="787878"/>
+                            <a:srgbClr val="1565C0"/>
                           </a:solidFill>
                         </a:rPr>
-                        <a:t>Needed</a:t>
+                        <a:t>Running</a:t>
                       </a:r>
                     </a:p>
                   </a:txBody>
@@ -9057,7 +9049,7 @@
                   <a:srgbClr val="212121"/>
                 </a:solidFill>
               </a:rPr>
-              <a:t>• v3 handoff baselines on the corrected scenario, including computed versus fixed lead and EdgeWarp timing (running).</a:t>
+              <a:t>• Trigger table on the corrected scenario: predictor-mode trigger, fixed leads, bands (T15, lookahead redo). The v3 baselines have landed.</a:t>
             </a:r>
           </a:p>
           <a:p>

</xml_diff>

<commit_message>
KB: relay_eval data README with harness pointers; deck baseline with q5 status
</commit_message>
<xml_diff>
--- a/docs/kb/decks/khonsu_story_2026-09-04.pptx
+++ b/docs/kb/decks/khonsu_story_2026-09-04.pptx
@@ -5552,7 +5552,7 @@
                   <a:srgbClr val="212121"/>
                 </a:solidFill>
               </a:rPr>
-              <a:t>Platoons of 1 to 16 tracks crossing together, plus the crossing-rate sweep. Measure p99 transfer-to-first-refresh latency against the available handoff budget (q5, burst scenario).</a:t>
+              <a:t>Landed (q5, 5 runs per cell): with 2, 4, and 8 oncoming vehicles, history 1 s ahead avoids a collision in 5, 2, and 4 runs, the handover snapshot in 0, 1, and 0, cold start in 0, 0, and 1. Still running: platoons of 1 to 16 tracks, p99 transfer-to-first-refresh latency against the handoff budget.</a:t>
             </a:r>
           </a:p>
         </p:txBody>
@@ -8691,7 +8691,7 @@
                     <a:p>
                       <a:r>
                         <a:rPr sz="1200" b="0"/>
-                        <a:t>q5 crossing rate, lookahead redo, computed-lead fix</a:t>
+                        <a:t>lookahead redo, computed-lead fix</a:t>
                       </a:r>
                     </a:p>
                   </a:txBody>
@@ -8749,7 +8749,7 @@
                     <a:p>
                       <a:r>
                         <a:rPr sz="1200" b="0"/>
-                        <a:t>burst: history ahead 5/5 vs EdgeWarp 0/5 vs cold 0/5</a:t>
+                        <a:t>burst: history ahead 5/5 vs EdgeWarp 0/5 vs cold 0/5; density 2/4/8: history 5,2,4 vs snapshot 0,1,0 vs cold 0,0,1 of 5</a:t>
                       </a:r>
                     </a:p>
                   </a:txBody>
@@ -8762,7 +8762,7 @@
                     <a:p>
                       <a:r>
                         <a:rPr sz="1200" b="0"/>
-                        <a:t>crossing-rate sweep (q5), corridor build (T13)</a:t>
+                        <a:t>platoon latency sweep, corridor build (T13)</a:t>
                       </a:r>
                     </a:p>
                   </a:txBody>
@@ -8836,7 +8836,7 @@
                   <a:srgbClr val="212121"/>
                 </a:solidFill>
               </a:rPr>
-              <a:t>Provenance. The first two sweeps ran an unvalidated scenario geometry (found Sep 3). The fix is a runner default, and v3 is the re-baseline.</a:t>
+              <a:t>Provenance. The first two sweeps ran an unvalidated scenario geometry (found Sep 3). The fix is a runner default. The canonical warm arm reproduced 4/4 under the documented settings, and v3 is the re-baseline.</a:t>
             </a:r>
           </a:p>
           <a:p>

</xml_diff>

<commit_message>
KB: figure completeness audit, T19-T22; deck baseline
</commit_message>
<xml_diff>
--- a/docs/kb/decks/khonsu_story_2026-09-04.pptx
+++ b/docs/kb/decks/khonsu_story_2026-09-04.pptx
@@ -5552,7 +5552,7 @@
                   <a:srgbClr val="212121"/>
                 </a:solidFill>
               </a:rPr>
-              <a:t>Landed (q5, 5 runs per cell): with 2, 4, and 8 oncoming vehicles, history 1 s ahead avoids a collision in 5, 2, and 4 runs, the handover snapshot in 0, 1, and 0, cold start in 0, 0, and 1. Still running: platoons of 1 to 16 tracks, p99 transfer-to-first-refresh latency against the handoff budget.</a:t>
+              <a:t>Landed (q5, 5 runs per cell): with 2, 4, and 8 oncoming vehicles, history 1 s ahead avoids a collision in 5, 2, and 4 runs, the handover snapshot in 0, 1, and 0, cold start in 0, 0, and 1. Needed: platoons of 1 to 16 tracks, p99 transfer-to-first-refresh latency against the handoff budget, with replication and dual-service overlap as arms (T19b).</a:t>
             </a:r>
           </a:p>
         </p:txBody>
@@ -7889,7 +7889,7 @@
             <a:avLst/>
           </a:prstGeom>
           <a:solidFill>
-            <a:srgbClr val="1565C0"/>
+            <a:srgbClr val="787878"/>
           </a:solidFill>
           <a:ln>
             <a:noFill/>
@@ -7920,7 +7920,7 @@
                   <a:srgbClr val="FFFFFF"/>
                 </a:solidFill>
               </a:rPr>
-              <a:t>Running</a:t>
+              <a:t>Needed</a:t>
             </a:r>
           </a:p>
         </p:txBody>
@@ -8096,7 +8096,7 @@
                   <a:srgbClr val="212121"/>
                 </a:solidFill>
               </a:rPr>
-              <a:t>Sweep locale side length. Fusion compute utilization comes from the canvas measurement. Handoff load comes from crossings per km at the corridor traffic (sizing study).</a:t>
+              <a:t>Sweep locale side length. Fusion compute utilization comes from the canvas measurement (in hand). Handoff load comes from crossings per boundary at the corridor traffic times the measured per-handoff cost (T22, analysis after T8 and T13).</a:t>
             </a:r>
           </a:p>
         </p:txBody>
@@ -8762,7 +8762,7 @@
                     <a:p>
                       <a:r>
                         <a:rPr sz="1200" b="0"/>
-                        <a:t>platoon latency sweep, corridor build (T13)</a:t>
+                        <a:t>corridor build (T13)</a:t>
                       </a:r>
                     </a:p>
                   </a:txBody>
@@ -8775,7 +8775,7 @@
                     <a:p>
                       <a:r>
                         <a:rPr sz="1200" b="0"/>
-                        <a:t>corridor route-level metrics (T13), association for unconnected actors (T10)</a:t>
+                        <a:t>crossing-load sweep (T19b), corridor route-level metrics (T13), sizing analysis (T22), association for unconnected actors (T10)</a:t>
                       </a:r>
                     </a:p>
                   </a:txBody>

</xml_diff>